<commit_message>
RA3-RA5: corregeix la llicència al peu de les diapositives de webgrafia
Mateixa correcció que a RA2: el material deriva de SMX-0226SI/Materials
(CC BY-SA 4.0), no de l'IOC (CC BY-NC-SA). Aplicat als 11 .pptx i PDF
de RA3, RA4 i RA5. Els PDF es regeneren amb la tipografia de la
plantilla (mateix text i mateix nombre de pàgines).

Co-Authored-By: Claude Opus 5.5 <noreply@anthropic.com>
Claude-Session: https://claude.ai/code/session_01BodJZ9PsepvknsFhsdyYkP
</commit_message>
<xml_diff>
--- a/RA3 - Seguretat activa/AA1 - Malware/RA3_AA1_Malware.pptx
+++ b/RA3 - Seguretat activa/AA1 - Malware/RA3_AA1_Malware.pptx
@@ -1962,6 +1962,10 @@
           </a:solidFill>
           <a:ln/>
         </p:spPr>
+        <p:txBody>
+          <a:bodyPr/>
+          <a:p/>
+        </p:txBody>
       </p:sp>
       <p:sp>
         <p:nvSpPr>
@@ -1982,6 +1986,10 @@
           </a:solidFill>
           <a:ln/>
         </p:spPr>
+        <p:txBody>
+          <a:bodyPr/>
+          <a:p/>
+        </p:txBody>
       </p:sp>
       <p:sp>
         <p:nvSpPr>
@@ -3115,6 +3123,10 @@
           </a:solidFill>
           <a:ln/>
         </p:spPr>
+        <p:txBody>
+          <a:bodyPr/>
+          <a:p/>
+        </p:txBody>
       </p:sp>
       <p:pic>
         <p:nvPicPr>
@@ -3364,6 +3376,10 @@
             </a:outerShdw>
           </a:effectLst>
         </p:spPr>
+        <p:txBody>
+          <a:bodyPr/>
+          <a:p/>
+        </p:txBody>
       </p:sp>
       <p:sp>
         <p:nvSpPr>
@@ -3384,6 +3400,10 @@
           </a:solidFill>
           <a:ln/>
         </p:spPr>
+        <p:txBody>
+          <a:bodyPr/>
+          <a:p/>
+        </p:txBody>
       </p:sp>
       <p:pic>
         <p:nvPicPr>
@@ -3523,6 +3543,10 @@
             </a:outerShdw>
           </a:effectLst>
         </p:spPr>
+        <p:txBody>
+          <a:bodyPr/>
+          <a:p/>
+        </p:txBody>
       </p:sp>
       <p:sp>
         <p:nvSpPr>
@@ -3543,6 +3567,10 @@
           </a:solidFill>
           <a:ln/>
         </p:spPr>
+        <p:txBody>
+          <a:bodyPr/>
+          <a:p/>
+        </p:txBody>
       </p:sp>
       <p:pic>
         <p:nvPicPr>
@@ -3682,6 +3710,10 @@
             </a:outerShdw>
           </a:effectLst>
         </p:spPr>
+        <p:txBody>
+          <a:bodyPr/>
+          <a:p/>
+        </p:txBody>
       </p:sp>
       <p:sp>
         <p:nvSpPr>
@@ -3702,6 +3734,10 @@
           </a:solidFill>
           <a:ln/>
         </p:spPr>
+        <p:txBody>
+          <a:bodyPr/>
+          <a:p/>
+        </p:txBody>
       </p:sp>
       <p:pic>
         <p:nvPicPr>
@@ -4625,7 +4661,7 @@
                 <a:ea typeface="Calibri" pitchFamily="34" charset="-122"/>
                 <a:cs typeface="Calibri" pitchFamily="34" charset="-120"/>
               </a:rPr>
-              <a:t>Llicència Creative Commons BY-NC-SA · Institut Obert de Catalunya, 2011 (materials adaptats i ampliats)</a:t>
+              <a:t>Llicència CC BY-SA 4.0 · Adaptat de "Materials" (SMX-0226SI), Carlos Alonso Martínez, Escola Pia de Mataró</a:t>
             </a:r>
             <a:endParaRPr lang="en-US" sz="1050" dirty="0"/>
           </a:p>
@@ -4852,6 +4888,10 @@
             </a:outerShdw>
           </a:effectLst>
         </p:spPr>
+        <p:txBody>
+          <a:bodyPr/>
+          <a:p/>
+        </p:txBody>
       </p:sp>
       <p:sp>
         <p:nvSpPr>
@@ -4872,6 +4912,10 @@
           </a:solidFill>
           <a:ln/>
         </p:spPr>
+        <p:txBody>
+          <a:bodyPr/>
+          <a:p/>
+        </p:txBody>
       </p:sp>
       <p:pic>
         <p:nvPicPr>
@@ -5011,6 +5055,10 @@
             </a:outerShdw>
           </a:effectLst>
         </p:spPr>
+        <p:txBody>
+          <a:bodyPr/>
+          <a:p/>
+        </p:txBody>
       </p:sp>
       <p:sp>
         <p:nvSpPr>
@@ -5031,6 +5079,10 @@
           </a:solidFill>
           <a:ln/>
         </p:spPr>
+        <p:txBody>
+          <a:bodyPr/>
+          <a:p/>
+        </p:txBody>
       </p:sp>
       <p:pic>
         <p:nvPicPr>
@@ -5170,6 +5222,10 @@
             </a:outerShdw>
           </a:effectLst>
         </p:spPr>
+        <p:txBody>
+          <a:bodyPr/>
+          <a:p/>
+        </p:txBody>
       </p:sp>
       <p:sp>
         <p:nvSpPr>
@@ -5190,6 +5246,10 @@
           </a:solidFill>
           <a:ln/>
         </p:spPr>
+        <p:txBody>
+          <a:bodyPr/>
+          <a:p/>
+        </p:txBody>
       </p:sp>
       <p:pic>
         <p:nvPicPr>
@@ -6544,6 +6604,10 @@
             </a:outerShdw>
           </a:effectLst>
         </p:spPr>
+        <p:txBody>
+          <a:bodyPr/>
+          <a:p/>
+        </p:txBody>
       </p:sp>
       <p:sp>
         <p:nvSpPr>
@@ -6564,6 +6628,10 @@
           </a:solidFill>
           <a:ln/>
         </p:spPr>
+        <p:txBody>
+          <a:bodyPr/>
+          <a:p/>
+        </p:txBody>
       </p:sp>
       <p:pic>
         <p:nvPicPr>
@@ -6703,6 +6771,10 @@
             </a:outerShdw>
           </a:effectLst>
         </p:spPr>
+        <p:txBody>
+          <a:bodyPr/>
+          <a:p/>
+        </p:txBody>
       </p:sp>
       <p:sp>
         <p:nvSpPr>
@@ -6723,6 +6795,10 @@
           </a:solidFill>
           <a:ln/>
         </p:spPr>
+        <p:txBody>
+          <a:bodyPr/>
+          <a:p/>
+        </p:txBody>
       </p:sp>
       <p:pic>
         <p:nvPicPr>
@@ -6850,6 +6926,10 @@
           </a:solidFill>
           <a:ln/>
         </p:spPr>
+        <p:txBody>
+          <a:bodyPr/>
+          <a:p/>
+        </p:txBody>
       </p:sp>
       <p:pic>
         <p:nvPicPr>
@@ -7181,6 +7261,10 @@
           </a:solidFill>
           <a:ln/>
         </p:spPr>
+        <p:txBody>
+          <a:bodyPr/>
+          <a:p/>
+        </p:txBody>
       </p:sp>
       <p:pic>
         <p:nvPicPr>
@@ -7649,6 +7733,10 @@
             </a:outerShdw>
           </a:effectLst>
         </p:spPr>
+        <p:txBody>
+          <a:bodyPr/>
+          <a:p/>
+        </p:txBody>
       </p:sp>
       <p:sp>
         <p:nvSpPr>
@@ -7669,6 +7757,10 @@
           </a:solidFill>
           <a:ln/>
         </p:spPr>
+        <p:txBody>
+          <a:bodyPr/>
+          <a:p/>
+        </p:txBody>
       </p:sp>
       <p:pic>
         <p:nvPicPr>
@@ -7808,6 +7900,10 @@
             </a:outerShdw>
           </a:effectLst>
         </p:spPr>
+        <p:txBody>
+          <a:bodyPr/>
+          <a:p/>
+        </p:txBody>
       </p:sp>
       <p:sp>
         <p:nvSpPr>
@@ -7828,6 +7924,10 @@
           </a:solidFill>
           <a:ln/>
         </p:spPr>
+        <p:txBody>
+          <a:bodyPr/>
+          <a:p/>
+        </p:txBody>
       </p:sp>
       <p:pic>
         <p:nvPicPr>
@@ -8222,6 +8322,10 @@
           </a:solidFill>
           <a:ln/>
         </p:spPr>
+        <p:txBody>
+          <a:bodyPr/>
+          <a:p/>
+        </p:txBody>
       </p:sp>
       <p:pic>
         <p:nvPicPr>

</xml_diff>